<commit_message>
Rebuild PPTX without raw-XML shape hacks for compatibility
Removes a manual prstGeom rewrite used to circle-crop headshots and an
unnecessary spTree re-ordering for background rectangles. Both were
schema-valid but non-standard; Google Slides failed to open the prior
export. Headshots now use a plain rectangular cover-crop via the
public crop_left/right/top/bottom API instead.
</commit_message>
<xml_diff>
--- a/media-kit/RVA-Builds-Media-Kit.pptx
+++ b/media-kit/RVA-Builds-Media-Kit.pptx
@@ -3778,7 +3778,7 @@
             <a:off x="868680" y="4251960"/>
             <a:ext cx="457200" cy="457200"/>
           </a:xfrm>
-          <a:prstGeom prst="ellipse">
+          <a:prstGeom prst="rect">
             <a:avLst/>
           </a:prstGeom>
         </p:spPr>
@@ -3968,7 +3968,7 @@
             <a:off x="4521098" y="4251960"/>
             <a:ext cx="457200" cy="457200"/>
           </a:xfrm>
-          <a:prstGeom prst="ellipse">
+          <a:prstGeom prst="rect">
             <a:avLst/>
           </a:prstGeom>
         </p:spPr>
@@ -4158,7 +4158,7 @@
             <a:off x="8173516" y="4251960"/>
             <a:ext cx="457200" cy="457200"/>
           </a:xfrm>
-          <a:prstGeom prst="ellipse">
+          <a:prstGeom prst="rect">
             <a:avLst/>
           </a:prstGeom>
         </p:spPr>

</xml_diff>

<commit_message>
Tailor slide copy closer to reference deck's instructional pattern
Rewrites the usage-rules, main-colors, secondary-colors, typography,
and photography slide descriptions with original RVA-specific wording
that mirrors the reference deck's structure and instructional tone
(clarity/color rules, trust framing, contrast usage, weight
flexibility, representation requirements) without reusing its text.
Regenerates the PDF and PPTX exports to match.
</commit_message>
<xml_diff>
--- a/media-kit/RVA-Builds-Media-Kit.pptx
+++ b/media-kit/RVA-Builds-Media-Kit.pptx
@@ -3545,7 +3545,7 @@
                 </a:solidFill>
                 <a:latin typeface="Schibsted Grotesk"/>
               </a:rPr>
-              <a:t>Two contrasting typefaces: Space Grotesk for headlines, Schibsted Grotesk for body.</a:t>
+              <a:t>Two contrasting typefaces: Space Grotesk for headlines, Schibsted Grotesk for body. Weights can vary, as long as the text stays legible.</a:t>
             </a:r>
           </a:p>
         </p:txBody>
@@ -5857,7 +5857,7 @@
                 </a:solidFill>
                 <a:latin typeface="Schibsted Grotesk"/>
               </a:rPr>
-              <a:t>Real Richmond students, families, and workplaces — candid, warm, full of natural light.</a:t>
+              <a:t>Photography must represent real Richmond students and workers on the job — inclusive of diverse ethnicities, ages, and trades. Illustrations should not be used.</a:t>
             </a:r>
           </a:p>
         </p:txBody>
@@ -8731,7 +8731,7 @@
                 </a:solidFill>
                 <a:latin typeface="Schibsted Grotesk"/>
               </a:rPr>
-              <a:t>Keep the mark consistent everywhere it appears.</a:t>
+              <a:t>No image or background should ever compete with the mark's clarity, and it must always appear in an approved color combination.</a:t>
             </a:r>
           </a:p>
         </p:txBody>
@@ -9222,7 +9222,7 @@
                 </a:solidFill>
                 <a:latin typeface="Schibsted Grotesk"/>
               </a:rPr>
-              <a:t>These are the colors that represent the identity of RVA Builds.</a:t>
+              <a:t>These colors represent the identity of RVA Builds — meant to build trust between candidates and employers.</a:t>
             </a:r>
           </a:p>
         </p:txBody>
@@ -10040,7 +10040,7 @@
                 </a:solidFill>
                 <a:latin typeface="Schibsted Grotesk"/>
               </a:rPr>
-              <a:t>Neutrals and status colors used for surfaces, text, and system states.</a:t>
+              <a:t>These create contrast against the main palette and should be used sparingly, for text, surfaces, and system states.</a:t>
             </a:r>
           </a:p>
         </p:txBody>

</xml_diff>

<commit_message>
Move Cover back to slide 1, About to slide 2
Reverts the opening order per feedback: Cover leads the deck again,
About/key facts follows. Also fixes a stray unbalanced </div> left
over from the earlier reorder. Regenerates PDF and PPTX.
</commit_message>
<xml_diff>
--- a/media-kit/RVA-Builds-Media-Kit.pptx
+++ b/media-kit/RVA-Builds-Media-Kit.pptx
@@ -3114,7 +3114,7 @@
             <a:avLst/>
           </a:prstGeom>
           <a:solidFill>
-            <a:srgbClr val="FFFFFF"/>
+            <a:srgbClr val="F15C2C"/>
           </a:solidFill>
           <a:ln>
             <a:noFill/>
@@ -3143,60 +3143,104 @@
           </a:p>
         </p:txBody>
       </p:sp>
-      <p:sp>
-        <p:nvSpPr>
-          <p:cNvPr id="3" name="Rectangle 2"/>
-          <p:cNvSpPr/>
-          <p:nvPr/>
-        </p:nvSpPr>
-        <p:spPr>
-          <a:xfrm>
-            <a:off x="0" y="0"/>
-            <a:ext cx="4145176" cy="6858000"/>
-          </a:xfrm>
-          <a:prstGeom prst="rect">
-            <a:avLst/>
-          </a:prstGeom>
-          <a:solidFill>
-            <a:srgbClr val="1A1A1A"/>
-          </a:solidFill>
-          <a:ln>
-            <a:noFill/>
-          </a:ln>
-          <a:effectLst/>
-        </p:spPr>
-        <p:style>
-          <a:lnRef idx="1">
-            <a:schemeClr val="accent1"/>
-          </a:lnRef>
-          <a:fillRef idx="3">
-            <a:schemeClr val="accent1"/>
-          </a:fillRef>
-          <a:effectRef idx="2">
-            <a:schemeClr val="accent1"/>
-          </a:effectRef>
-          <a:fontRef idx="minor">
-            <a:schemeClr val="lt1"/>
-          </a:fontRef>
-        </p:style>
-        <p:txBody>
-          <a:bodyPr rtlCol="0" anchor="ctr"/>
-          <a:lstStyle/>
-          <a:p>
-            <a:pPr algn="ctr"/>
-          </a:p>
-        </p:txBody>
-      </p:sp>
-      <p:sp>
-        <p:nvSpPr>
-          <p:cNvPr id="4" name="TextBox 3"/>
+      <p:pic>
+        <p:nvPicPr>
+          <p:cNvPr id="3" name="Picture 2" descr="hero-connection.jpg"/>
+          <p:cNvPicPr>
+            <a:picLocks noChangeAspect="1"/>
+          </p:cNvPicPr>
+          <p:nvPr/>
+        </p:nvPicPr>
+        <p:blipFill>
+          <a:blip r:embed="rId2"/>
+          <a:srcRect l="5561" r="5561"/>
+          <a:stretch>
+            <a:fillRect/>
+          </a:stretch>
+        </p:blipFill>
+        <p:spPr>
+          <a:xfrm>
+            <a:off x="4145176" y="0"/>
+            <a:ext cx="8046519" cy="6858000"/>
+          </a:xfrm>
+          <a:prstGeom prst="rect">
+            <a:avLst/>
+          </a:prstGeom>
+        </p:spPr>
+      </p:pic>
+      <p:pic>
+        <p:nvPicPr>
+          <p:cNvPr id="4" name="Picture 3" descr="rva-builds-icon.png"/>
+          <p:cNvPicPr>
+            <a:picLocks noChangeAspect="1"/>
+          </p:cNvPicPr>
+          <p:nvPr/>
+        </p:nvPicPr>
+        <p:blipFill>
+          <a:blip r:embed="rId3"/>
+          <a:stretch>
+            <a:fillRect/>
+          </a:stretch>
+        </p:blipFill>
+        <p:spPr>
+          <a:xfrm>
+            <a:off x="548640" y="4160520"/>
+            <a:ext cx="365760" cy="365760"/>
+          </a:xfrm>
+          <a:prstGeom prst="rect">
+            <a:avLst/>
+          </a:prstGeom>
+        </p:spPr>
+      </p:pic>
+      <p:sp>
+        <p:nvSpPr>
+          <p:cNvPr id="5" name="TextBox 4"/>
           <p:cNvSpPr txBox="1"/>
           <p:nvPr/>
         </p:nvSpPr>
         <p:spPr>
           <a:xfrm>
-            <a:off x="411480" y="2331720"/>
-            <a:ext cx="3322216" cy="274320"/>
+            <a:off x="960120" y="4160520"/>
+            <a:ext cx="3200400" cy="365760"/>
+          </a:xfrm>
+          <a:prstGeom prst="rect">
+            <a:avLst/>
+          </a:prstGeom>
+          <a:noFill/>
+        </p:spPr>
+        <p:txBody>
+          <a:bodyPr wrap="square" anchor="ctr" lIns="0" rIns="0" tIns="0" bIns="0">
+            <a:spAutoFit/>
+          </a:bodyPr>
+          <a:lstStyle/>
+          <a:p>
+            <a:pPr algn="l">
+              <a:lnSpc>
+                <a:spcPct val="100000"/>
+              </a:lnSpc>
+            </a:pPr>
+            <a:r>
+              <a:rPr sz="1500" b="0">
+                <a:solidFill>
+                  <a:srgbClr val="FFFFFF"/>
+                </a:solidFill>
+                <a:latin typeface="Space Grotesk"/>
+              </a:rPr>
+              <a:t>RVA Builds</a:t>
+            </a:r>
+          </a:p>
+        </p:txBody>
+      </p:sp>
+      <p:sp>
+        <p:nvSpPr>
+          <p:cNvPr id="6" name="TextBox 5"/>
+          <p:cNvSpPr txBox="1"/>
+          <p:nvPr/>
+        </p:nvSpPr>
+        <p:spPr>
+          <a:xfrm>
+            <a:off x="548640" y="4709160"/>
+            <a:ext cx="3657600" cy="457200"/>
           </a:xfrm>
           <a:prstGeom prst="rect">
             <a:avLst/>
@@ -3209,33 +3253,33 @@
           </a:bodyPr>
           <a:lstStyle/>
           <a:p>
-            <a:pPr algn="ctr">
+            <a:pPr algn="l">
               <a:lnSpc>
                 <a:spcPct val="100000"/>
               </a:lnSpc>
             </a:pPr>
             <a:r>
-              <a:rPr sz="1200" b="1">
-                <a:solidFill>
-                  <a:srgbClr val="F15C2C"/>
+              <a:rPr sz="1050" b="1">
+                <a:solidFill>
+                  <a:srgbClr val="FFE3D8"/>
                 </a:solidFill>
                 <a:latin typeface="Space Grotesk"/>
               </a:rPr>
-              <a:t>01</a:t>
-            </a:r>
-          </a:p>
-        </p:txBody>
-      </p:sp>
-      <p:sp>
-        <p:nvSpPr>
-          <p:cNvPr id="5" name="TextBox 4"/>
+              <a:t>RICHMOND ED FUND INITIATIVE</a:t>
+            </a:r>
+          </a:p>
+        </p:txBody>
+      </p:sp>
+      <p:sp>
+        <p:nvSpPr>
+          <p:cNvPr id="7" name="TextBox 6"/>
           <p:cNvSpPr txBox="1"/>
           <p:nvPr/>
         </p:nvSpPr>
         <p:spPr>
           <a:xfrm>
-            <a:off x="411480" y="2651760"/>
-            <a:ext cx="3322216" cy="1005840"/>
+            <a:off x="548640" y="5074920"/>
+            <a:ext cx="3657600" cy="1280160"/>
           </a:xfrm>
           <a:prstGeom prst="rect">
             <a:avLst/>
@@ -3248,568 +3292,35 @@
           </a:bodyPr>
           <a:lstStyle/>
           <a:p>
-            <a:pPr algn="ctr">
-              <a:lnSpc>
-                <a:spcPct val="105000"/>
-              </a:lnSpc>
-            </a:pPr>
-            <a:r>
-              <a:rPr sz="2600" b="1">
+            <a:pPr algn="l">
+              <a:lnSpc>
+                <a:spcPct val="100000"/>
+              </a:lnSpc>
+            </a:pPr>
+            <a:r>
+              <a:rPr sz="4400" b="1">
                 <a:solidFill>
                   <a:srgbClr val="FFFFFF"/>
                 </a:solidFill>
                 <a:latin typeface="Space Grotesk"/>
               </a:rPr>
-              <a:t>What is</a:t>
-            </a:r>
-          </a:p>
-          <a:p>
-            <a:pPr algn="ctr">
-              <a:lnSpc>
-                <a:spcPct val="105000"/>
-              </a:lnSpc>
-            </a:pPr>
-            <a:r>
-              <a:rPr sz="2600" b="1">
+              <a:t>MEDIA</a:t>
+            </a:r>
+          </a:p>
+          <a:p>
+            <a:pPr algn="l">
+              <a:lnSpc>
+                <a:spcPct val="100000"/>
+              </a:lnSpc>
+            </a:pPr>
+            <a:r>
+              <a:rPr sz="4400" b="1">
                 <a:solidFill>
                   <a:srgbClr val="FFFFFF"/>
                 </a:solidFill>
                 <a:latin typeface="Space Grotesk"/>
               </a:rPr>
-              <a:t>RVA Builds?</a:t>
-            </a:r>
-          </a:p>
-        </p:txBody>
-      </p:sp>
-      <p:sp>
-        <p:nvSpPr>
-          <p:cNvPr id="6" name="TextBox 5"/>
-          <p:cNvSpPr txBox="1"/>
-          <p:nvPr/>
-        </p:nvSpPr>
-        <p:spPr>
-          <a:xfrm>
-            <a:off x="411480" y="3703320"/>
-            <a:ext cx="3322216" cy="1280160"/>
-          </a:xfrm>
-          <a:prstGeom prst="rect">
-            <a:avLst/>
-          </a:prstGeom>
-          <a:noFill/>
-        </p:spPr>
-        <p:txBody>
-          <a:bodyPr wrap="square" anchor="t" lIns="0" rIns="0" tIns="0" bIns="0">
-            <a:spAutoFit/>
-          </a:bodyPr>
-          <a:lstStyle/>
-          <a:p>
-            <a:pPr algn="ctr">
-              <a:lnSpc>
-                <a:spcPct val="135000"/>
-              </a:lnSpc>
-            </a:pPr>
-            <a:r>
-              <a:rPr sz="1300" b="0">
-                <a:solidFill>
-                  <a:srgbClr val="CCCCCC"/>
-                </a:solidFill>
-                <a:latin typeface="Schibsted Grotesk"/>
-              </a:rPr>
-              <a:t>RVA Builds connects Richmond Public Schools students with paid, hands-on careers in construction and the skilled trades — before they even graduate. A Richmond Ed Fund initiative, backed by Bloomberg Philanthropies.</a:t>
-            </a:r>
-          </a:p>
-        </p:txBody>
-      </p:sp>
-      <p:cxnSp>
-        <p:nvCxnSpPr>
-          <p:cNvPr id="7" name="Connector 6"/>
-          <p:cNvCxnSpPr/>
-          <p:nvPr/>
-        </p:nvCxnSpPr>
-        <p:spPr>
-          <a:xfrm>
-            <a:off x="5150915.5" y="2331720"/>
-            <a:ext cx="6035040.0" cy="0"/>
-          </a:xfrm>
-          <a:prstGeom prst="line">
-            <a:avLst/>
-          </a:prstGeom>
-          <a:ln w="12700">
-            <a:solidFill>
-              <a:srgbClr val="E4E4E4"/>
-            </a:solidFill>
-          </a:ln>
-        </p:spPr>
-        <p:style>
-          <a:lnRef idx="2">
-            <a:schemeClr val="accent1"/>
-          </a:lnRef>
-          <a:fillRef idx="0">
-            <a:schemeClr val="accent1"/>
-          </a:fillRef>
-          <a:effectRef idx="1">
-            <a:schemeClr val="accent1"/>
-          </a:effectRef>
-          <a:fontRef idx="minor">
-            <a:schemeClr val="tx1"/>
-          </a:fontRef>
-        </p:style>
-      </p:cxnSp>
-      <p:cxnSp>
-        <p:nvCxnSpPr>
-          <p:cNvPr id="8" name="Connector 7"/>
-          <p:cNvCxnSpPr/>
-          <p:nvPr/>
-        </p:nvCxnSpPr>
-        <p:spPr>
-          <a:xfrm>
-            <a:off x="5150915.5" y="3566160"/>
-            <a:ext cx="6035040.0" cy="0"/>
-          </a:xfrm>
-          <a:prstGeom prst="line">
-            <a:avLst/>
-          </a:prstGeom>
-          <a:ln w="12700">
-            <a:solidFill>
-              <a:srgbClr val="E4E4E4"/>
-            </a:solidFill>
-          </a:ln>
-        </p:spPr>
-        <p:style>
-          <a:lnRef idx="2">
-            <a:schemeClr val="accent1"/>
-          </a:lnRef>
-          <a:fillRef idx="0">
-            <a:schemeClr val="accent1"/>
-          </a:fillRef>
-          <a:effectRef idx="1">
-            <a:schemeClr val="accent1"/>
-          </a:effectRef>
-          <a:fontRef idx="minor">
-            <a:schemeClr val="tx1"/>
-          </a:fontRef>
-        </p:style>
-      </p:cxnSp>
-      <p:sp>
-        <p:nvSpPr>
-          <p:cNvPr id="9" name="TextBox 8"/>
-          <p:cNvSpPr txBox="1"/>
-          <p:nvPr/>
-        </p:nvSpPr>
-        <p:spPr>
-          <a:xfrm>
-            <a:off x="5150915" y="2514600"/>
-            <a:ext cx="1371600" cy="548640"/>
-          </a:xfrm>
-          <a:prstGeom prst="rect">
-            <a:avLst/>
-          </a:prstGeom>
-          <a:noFill/>
-        </p:spPr>
-        <p:txBody>
-          <a:bodyPr wrap="square" anchor="t" lIns="0" rIns="0" tIns="0" bIns="0">
-            <a:spAutoFit/>
-          </a:bodyPr>
-          <a:lstStyle/>
-          <a:p>
-            <a:pPr algn="l">
-              <a:lnSpc>
-                <a:spcPct val="100000"/>
-              </a:lnSpc>
-            </a:pPr>
-            <a:r>
-              <a:rPr sz="3200" b="1">
-                <a:solidFill>
-                  <a:srgbClr val="1A1A1A"/>
-                </a:solidFill>
-                <a:latin typeface="Space Grotesk"/>
-              </a:rPr>
-              <a:t>150</a:t>
-            </a:r>
-          </a:p>
-        </p:txBody>
-      </p:sp>
-      <p:sp>
-        <p:nvSpPr>
-          <p:cNvPr id="10" name="TextBox 9"/>
-          <p:cNvSpPr txBox="1"/>
-          <p:nvPr/>
-        </p:nvSpPr>
-        <p:spPr>
-          <a:xfrm>
-            <a:off x="5150915" y="3108960"/>
-            <a:ext cx="1371600" cy="502920"/>
-          </a:xfrm>
-          <a:prstGeom prst="rect">
-            <a:avLst/>
-          </a:prstGeom>
-          <a:noFill/>
-        </p:spPr>
-        <p:txBody>
-          <a:bodyPr wrap="square" anchor="t" lIns="0" rIns="0" tIns="0" bIns="0">
-            <a:spAutoFit/>
-          </a:bodyPr>
-          <a:lstStyle/>
-          <a:p>
-            <a:pPr algn="l">
-              <a:lnSpc>
-                <a:spcPct val="115000"/>
-              </a:lnSpc>
-            </a:pPr>
-            <a:r>
-              <a:rPr sz="1050" b="0">
-                <a:solidFill>
-                  <a:srgbClr val="5A5A5A"/>
-                </a:solidFill>
-                <a:latin typeface="Schibsted Grotesk"/>
-              </a:rPr>
-              <a:t>RPS grads aimed at registered</a:t>
-            </a:r>
-          </a:p>
-          <a:p>
-            <a:pPr algn="l">
-              <a:lnSpc>
-                <a:spcPct val="115000"/>
-              </a:lnSpc>
-            </a:pPr>
-            <a:r>
-              <a:rPr sz="1050" b="0">
-                <a:solidFill>
-                  <a:srgbClr val="5A5A5A"/>
-                </a:solidFill>
-                <a:latin typeface="Schibsted Grotesk"/>
-              </a:rPr>
-              <a:t>apprenticeships in 3 years</a:t>
-            </a:r>
-          </a:p>
-        </p:txBody>
-      </p:sp>
-      <p:sp>
-        <p:nvSpPr>
-          <p:cNvPr id="11" name="TextBox 10"/>
-          <p:cNvSpPr txBox="1"/>
-          <p:nvPr/>
-        </p:nvSpPr>
-        <p:spPr>
-          <a:xfrm>
-            <a:off x="6659675" y="2514600"/>
-            <a:ext cx="1371600" cy="548640"/>
-          </a:xfrm>
-          <a:prstGeom prst="rect">
-            <a:avLst/>
-          </a:prstGeom>
-          <a:noFill/>
-        </p:spPr>
-        <p:txBody>
-          <a:bodyPr wrap="square" anchor="t" lIns="0" rIns="0" tIns="0" bIns="0">
-            <a:spAutoFit/>
-          </a:bodyPr>
-          <a:lstStyle/>
-          <a:p>
-            <a:pPr algn="l">
-              <a:lnSpc>
-                <a:spcPct val="100000"/>
-              </a:lnSpc>
-            </a:pPr>
-            <a:r>
-              <a:rPr sz="3200" b="1">
-                <a:solidFill>
-                  <a:srgbClr val="1A1A1A"/>
-                </a:solidFill>
-                <a:latin typeface="Space Grotesk"/>
-              </a:rPr>
-              <a:t>500</a:t>
-            </a:r>
-          </a:p>
-        </p:txBody>
-      </p:sp>
-      <p:sp>
-        <p:nvSpPr>
-          <p:cNvPr id="12" name="TextBox 11"/>
-          <p:cNvSpPr txBox="1"/>
-          <p:nvPr/>
-        </p:nvSpPr>
-        <p:spPr>
-          <a:xfrm>
-            <a:off x="6659675" y="3108960"/>
-            <a:ext cx="1371600" cy="502920"/>
-          </a:xfrm>
-          <a:prstGeom prst="rect">
-            <a:avLst/>
-          </a:prstGeom>
-          <a:noFill/>
-        </p:spPr>
-        <p:txBody>
-          <a:bodyPr wrap="square" anchor="t" lIns="0" rIns="0" tIns="0" bIns="0">
-            <a:spAutoFit/>
-          </a:bodyPr>
-          <a:lstStyle/>
-          <a:p>
-            <a:pPr algn="l">
-              <a:lnSpc>
-                <a:spcPct val="115000"/>
-              </a:lnSpc>
-            </a:pPr>
-            <a:r>
-              <a:rPr sz="1050" b="0">
-                <a:solidFill>
-                  <a:srgbClr val="5A5A5A"/>
-                </a:solidFill>
-                <a:latin typeface="Schibsted Grotesk"/>
-              </a:rPr>
-              <a:t>Students in paid trades</a:t>
-            </a:r>
-          </a:p>
-          <a:p>
-            <a:pPr algn="l">
-              <a:lnSpc>
-                <a:spcPct val="115000"/>
-              </a:lnSpc>
-            </a:pPr>
-            <a:r>
-              <a:rPr sz="1050" b="0">
-                <a:solidFill>
-                  <a:srgbClr val="5A5A5A"/>
-                </a:solidFill>
-                <a:latin typeface="Schibsted Grotesk"/>
-              </a:rPr>
-              <a:t>learning by 2028–29 (goal)</a:t>
-            </a:r>
-          </a:p>
-        </p:txBody>
-      </p:sp>
-      <p:sp>
-        <p:nvSpPr>
-          <p:cNvPr id="13" name="TextBox 12"/>
-          <p:cNvSpPr txBox="1"/>
-          <p:nvPr/>
-        </p:nvSpPr>
-        <p:spPr>
-          <a:xfrm>
-            <a:off x="8168435" y="2514600"/>
-            <a:ext cx="1371600" cy="548640"/>
-          </a:xfrm>
-          <a:prstGeom prst="rect">
-            <a:avLst/>
-          </a:prstGeom>
-          <a:noFill/>
-        </p:spPr>
-        <p:txBody>
-          <a:bodyPr wrap="square" anchor="t" lIns="0" rIns="0" tIns="0" bIns="0">
-            <a:spAutoFit/>
-          </a:bodyPr>
-          <a:lstStyle/>
-          <a:p>
-            <a:pPr algn="l">
-              <a:lnSpc>
-                <a:spcPct val="100000"/>
-              </a:lnSpc>
-            </a:pPr>
-            <a:r>
-              <a:rPr sz="3200" b="1">
-                <a:solidFill>
-                  <a:srgbClr val="1A1A1A"/>
-                </a:solidFill>
-                <a:latin typeface="Space Grotesk"/>
-              </a:rPr>
-              <a:t>17</a:t>
-            </a:r>
-          </a:p>
-        </p:txBody>
-      </p:sp>
-      <p:sp>
-        <p:nvSpPr>
-          <p:cNvPr id="14" name="TextBox 13"/>
-          <p:cNvSpPr txBox="1"/>
-          <p:nvPr/>
-        </p:nvSpPr>
-        <p:spPr>
-          <a:xfrm>
-            <a:off x="8168435" y="3108960"/>
-            <a:ext cx="1371600" cy="502920"/>
-          </a:xfrm>
-          <a:prstGeom prst="rect">
-            <a:avLst/>
-          </a:prstGeom>
-          <a:noFill/>
-        </p:spPr>
-        <p:txBody>
-          <a:bodyPr wrap="square" anchor="t" lIns="0" rIns="0" tIns="0" bIns="0">
-            <a:spAutoFit/>
-          </a:bodyPr>
-          <a:lstStyle/>
-          <a:p>
-            <a:pPr algn="l">
-              <a:lnSpc>
-                <a:spcPct val="115000"/>
-              </a:lnSpc>
-            </a:pPr>
-            <a:r>
-              <a:rPr sz="1050" b="0">
-                <a:solidFill>
-                  <a:srgbClr val="5A5A5A"/>
-                </a:solidFill>
-                <a:latin typeface="Schibsted Grotesk"/>
-              </a:rPr>
-              <a:t>Partners: schools, the city,</a:t>
-            </a:r>
-          </a:p>
-          <a:p>
-            <a:pPr algn="l">
-              <a:lnSpc>
-                <a:spcPct val="115000"/>
-              </a:lnSpc>
-            </a:pPr>
-            <a:r>
-              <a:rPr sz="1050" b="0">
-                <a:solidFill>
-                  <a:srgbClr val="5A5A5A"/>
-                </a:solidFill>
-                <a:latin typeface="Schibsted Grotesk"/>
-              </a:rPr>
-              <a:t>business &amp; unions</a:t>
-            </a:r>
-          </a:p>
-        </p:txBody>
-      </p:sp>
-      <p:sp>
-        <p:nvSpPr>
-          <p:cNvPr id="15" name="TextBox 14"/>
-          <p:cNvSpPr txBox="1"/>
-          <p:nvPr/>
-        </p:nvSpPr>
-        <p:spPr>
-          <a:xfrm>
-            <a:off x="9677195" y="2514600"/>
-            <a:ext cx="1371600" cy="548640"/>
-          </a:xfrm>
-          <a:prstGeom prst="rect">
-            <a:avLst/>
-          </a:prstGeom>
-          <a:noFill/>
-        </p:spPr>
-        <p:txBody>
-          <a:bodyPr wrap="square" anchor="t" lIns="0" rIns="0" tIns="0" bIns="0">
-            <a:spAutoFit/>
-          </a:bodyPr>
-          <a:lstStyle/>
-          <a:p>
-            <a:pPr algn="l">
-              <a:lnSpc>
-                <a:spcPct val="100000"/>
-              </a:lnSpc>
-            </a:pPr>
-            <a:r>
-              <a:rPr sz="3200" b="1">
-                <a:solidFill>
-                  <a:srgbClr val="1A1A1A"/>
-                </a:solidFill>
-                <a:latin typeface="Space Grotesk"/>
-              </a:rPr>
-              <a:t>120+</a:t>
-            </a:r>
-          </a:p>
-        </p:txBody>
-      </p:sp>
-      <p:sp>
-        <p:nvSpPr>
-          <p:cNvPr id="16" name="TextBox 15"/>
-          <p:cNvSpPr txBox="1"/>
-          <p:nvPr/>
-        </p:nvSpPr>
-        <p:spPr>
-          <a:xfrm>
-            <a:off x="9677195" y="3108960"/>
-            <a:ext cx="1371600" cy="502920"/>
-          </a:xfrm>
-          <a:prstGeom prst="rect">
-            <a:avLst/>
-          </a:prstGeom>
-          <a:noFill/>
-        </p:spPr>
-        <p:txBody>
-          <a:bodyPr wrap="square" anchor="t" lIns="0" rIns="0" tIns="0" bIns="0">
-            <a:spAutoFit/>
-          </a:bodyPr>
-          <a:lstStyle/>
-          <a:p>
-            <a:pPr algn="l">
-              <a:lnSpc>
-                <a:spcPct val="115000"/>
-              </a:lnSpc>
-            </a:pPr>
-            <a:r>
-              <a:rPr sz="1050" b="0">
-                <a:solidFill>
-                  <a:srgbClr val="5A5A5A"/>
-                </a:solidFill>
-                <a:latin typeface="Schibsted Grotesk"/>
-              </a:rPr>
-              <a:t>Paid work-based learning</a:t>
-            </a:r>
-          </a:p>
-          <a:p>
-            <a:pPr algn="l">
-              <a:lnSpc>
-                <a:spcPct val="115000"/>
-              </a:lnSpc>
-            </a:pPr>
-            <a:r>
-              <a:rPr sz="1050" b="0">
-                <a:solidFill>
-                  <a:srgbClr val="5A5A5A"/>
-                </a:solidFill>
-                <a:latin typeface="Schibsted Grotesk"/>
-              </a:rPr>
-              <a:t>hours per student</a:t>
-            </a:r>
-          </a:p>
-        </p:txBody>
-      </p:sp>
-      <p:sp>
-        <p:nvSpPr>
-          <p:cNvPr id="17" name="TextBox 16"/>
-          <p:cNvSpPr txBox="1"/>
-          <p:nvPr/>
-        </p:nvSpPr>
-        <p:spPr>
-          <a:xfrm>
-            <a:off x="4145176" y="4023360"/>
-            <a:ext cx="8046519" cy="548640"/>
-          </a:xfrm>
-          <a:prstGeom prst="rect">
-            <a:avLst/>
-          </a:prstGeom>
-          <a:noFill/>
-        </p:spPr>
-        <p:txBody>
-          <a:bodyPr wrap="square" anchor="t" lIns="0" rIns="0">
-            <a:spAutoFit/>
-          </a:bodyPr>
-          <a:lstStyle/>
-          <a:p>
-            <a:pPr algn="ctr">
-              <a:lnSpc>
-                <a:spcPct val="100000"/>
-              </a:lnSpc>
-            </a:pPr>
-            <a:r>
-              <a:rPr sz="1900" b="1">
-                <a:solidFill>
-                  <a:srgbClr val="1A1A1A"/>
-                </a:solidFill>
-                <a:latin typeface="Space Grotesk"/>
-              </a:rPr>
-              <a:t>Build a career in the trades, </a:t>
-            </a:r>
-            <a:r>
-              <a:rPr sz="1900" b="1">
-                <a:solidFill>
-                  <a:srgbClr val="F15C2C"/>
-                </a:solidFill>
-                <a:latin typeface="Space Grotesk"/>
-              </a:rPr>
-              <a:t>before you graduate.</a:t>
+              <a:t>KIT</a:t>
             </a:r>
           </a:p>
         </p:txBody>
@@ -5797,7 +5308,7 @@
             <a:avLst/>
           </a:prstGeom>
           <a:solidFill>
-            <a:srgbClr val="F15C2C"/>
+            <a:srgbClr val="FFFFFF"/>
           </a:solidFill>
           <a:ln>
             <a:noFill/>
@@ -5826,104 +5337,60 @@
           </a:p>
         </p:txBody>
       </p:sp>
-      <p:pic>
-        <p:nvPicPr>
-          <p:cNvPr id="3" name="Picture 2" descr="hero-connection.jpg"/>
-          <p:cNvPicPr>
-            <a:picLocks noChangeAspect="1"/>
-          </p:cNvPicPr>
-          <p:nvPr/>
-        </p:nvPicPr>
-        <p:blipFill>
-          <a:blip r:embed="rId2"/>
-          <a:srcRect l="5561" r="5561"/>
-          <a:stretch>
-            <a:fillRect/>
-          </a:stretch>
-        </p:blipFill>
-        <p:spPr>
-          <a:xfrm>
-            <a:off x="4145176" y="0"/>
-            <a:ext cx="8046519" cy="6858000"/>
-          </a:xfrm>
-          <a:prstGeom prst="rect">
-            <a:avLst/>
-          </a:prstGeom>
-        </p:spPr>
-      </p:pic>
-      <p:pic>
-        <p:nvPicPr>
-          <p:cNvPr id="4" name="Picture 3" descr="rva-builds-icon.png"/>
-          <p:cNvPicPr>
-            <a:picLocks noChangeAspect="1"/>
-          </p:cNvPicPr>
-          <p:nvPr/>
-        </p:nvPicPr>
-        <p:blipFill>
-          <a:blip r:embed="rId3"/>
-          <a:stretch>
-            <a:fillRect/>
-          </a:stretch>
-        </p:blipFill>
-        <p:spPr>
-          <a:xfrm>
-            <a:off x="548640" y="4160520"/>
-            <a:ext cx="365760" cy="365760"/>
-          </a:xfrm>
-          <a:prstGeom prst="rect">
-            <a:avLst/>
-          </a:prstGeom>
-        </p:spPr>
-      </p:pic>
-      <p:sp>
-        <p:nvSpPr>
-          <p:cNvPr id="5" name="TextBox 4"/>
+      <p:sp>
+        <p:nvSpPr>
+          <p:cNvPr id="3" name="Rectangle 2"/>
+          <p:cNvSpPr/>
+          <p:nvPr/>
+        </p:nvSpPr>
+        <p:spPr>
+          <a:xfrm>
+            <a:off x="0" y="0"/>
+            <a:ext cx="4145176" cy="6858000"/>
+          </a:xfrm>
+          <a:prstGeom prst="rect">
+            <a:avLst/>
+          </a:prstGeom>
+          <a:solidFill>
+            <a:srgbClr val="1A1A1A"/>
+          </a:solidFill>
+          <a:ln>
+            <a:noFill/>
+          </a:ln>
+          <a:effectLst/>
+        </p:spPr>
+        <p:style>
+          <a:lnRef idx="1">
+            <a:schemeClr val="accent1"/>
+          </a:lnRef>
+          <a:fillRef idx="3">
+            <a:schemeClr val="accent1"/>
+          </a:fillRef>
+          <a:effectRef idx="2">
+            <a:schemeClr val="accent1"/>
+          </a:effectRef>
+          <a:fontRef idx="minor">
+            <a:schemeClr val="lt1"/>
+          </a:fontRef>
+        </p:style>
+        <p:txBody>
+          <a:bodyPr rtlCol="0" anchor="ctr"/>
+          <a:lstStyle/>
+          <a:p>
+            <a:pPr algn="ctr"/>
+          </a:p>
+        </p:txBody>
+      </p:sp>
+      <p:sp>
+        <p:nvSpPr>
+          <p:cNvPr id="4" name="TextBox 3"/>
           <p:cNvSpPr txBox="1"/>
           <p:nvPr/>
         </p:nvSpPr>
         <p:spPr>
           <a:xfrm>
-            <a:off x="960120" y="4160520"/>
-            <a:ext cx="3200400" cy="365760"/>
-          </a:xfrm>
-          <a:prstGeom prst="rect">
-            <a:avLst/>
-          </a:prstGeom>
-          <a:noFill/>
-        </p:spPr>
-        <p:txBody>
-          <a:bodyPr wrap="square" anchor="ctr" lIns="0" rIns="0" tIns="0" bIns="0">
-            <a:spAutoFit/>
-          </a:bodyPr>
-          <a:lstStyle/>
-          <a:p>
-            <a:pPr algn="l">
-              <a:lnSpc>
-                <a:spcPct val="100000"/>
-              </a:lnSpc>
-            </a:pPr>
-            <a:r>
-              <a:rPr sz="1500" b="0">
-                <a:solidFill>
-                  <a:srgbClr val="FFFFFF"/>
-                </a:solidFill>
-                <a:latin typeface="Space Grotesk"/>
-              </a:rPr>
-              <a:t>RVA Builds</a:t>
-            </a:r>
-          </a:p>
-        </p:txBody>
-      </p:sp>
-      <p:sp>
-        <p:nvSpPr>
-          <p:cNvPr id="6" name="TextBox 5"/>
-          <p:cNvSpPr txBox="1"/>
-          <p:nvPr/>
-        </p:nvSpPr>
-        <p:spPr>
-          <a:xfrm>
-            <a:off x="548640" y="4709160"/>
-            <a:ext cx="3657600" cy="457200"/>
+            <a:off x="411480" y="2331720"/>
+            <a:ext cx="3322216" cy="274320"/>
           </a:xfrm>
           <a:prstGeom prst="rect">
             <a:avLst/>
@@ -5936,33 +5403,33 @@
           </a:bodyPr>
           <a:lstStyle/>
           <a:p>
-            <a:pPr algn="l">
+            <a:pPr algn="ctr">
               <a:lnSpc>
                 <a:spcPct val="100000"/>
               </a:lnSpc>
             </a:pPr>
             <a:r>
-              <a:rPr sz="1050" b="1">
-                <a:solidFill>
-                  <a:srgbClr val="FFE3D8"/>
+              <a:rPr sz="1200" b="1">
+                <a:solidFill>
+                  <a:srgbClr val="F15C2C"/>
                 </a:solidFill>
                 <a:latin typeface="Space Grotesk"/>
               </a:rPr>
-              <a:t>RICHMOND ED FUND INITIATIVE</a:t>
-            </a:r>
-          </a:p>
-        </p:txBody>
-      </p:sp>
-      <p:sp>
-        <p:nvSpPr>
-          <p:cNvPr id="7" name="TextBox 6"/>
+              <a:t>01</a:t>
+            </a:r>
+          </a:p>
+        </p:txBody>
+      </p:sp>
+      <p:sp>
+        <p:nvSpPr>
+          <p:cNvPr id="5" name="TextBox 4"/>
           <p:cNvSpPr txBox="1"/>
           <p:nvPr/>
         </p:nvSpPr>
         <p:spPr>
           <a:xfrm>
-            <a:off x="548640" y="5074920"/>
-            <a:ext cx="3657600" cy="1280160"/>
+            <a:off x="411480" y="2651760"/>
+            <a:ext cx="3322216" cy="1005840"/>
           </a:xfrm>
           <a:prstGeom prst="rect">
             <a:avLst/>
@@ -5975,35 +5442,568 @@
           </a:bodyPr>
           <a:lstStyle/>
           <a:p>
+            <a:pPr algn="ctr">
+              <a:lnSpc>
+                <a:spcPct val="105000"/>
+              </a:lnSpc>
+            </a:pPr>
+            <a:r>
+              <a:rPr sz="2600" b="1">
+                <a:solidFill>
+                  <a:srgbClr val="FFFFFF"/>
+                </a:solidFill>
+                <a:latin typeface="Space Grotesk"/>
+              </a:rPr>
+              <a:t>What is</a:t>
+            </a:r>
+          </a:p>
+          <a:p>
+            <a:pPr algn="ctr">
+              <a:lnSpc>
+                <a:spcPct val="105000"/>
+              </a:lnSpc>
+            </a:pPr>
+            <a:r>
+              <a:rPr sz="2600" b="1">
+                <a:solidFill>
+                  <a:srgbClr val="FFFFFF"/>
+                </a:solidFill>
+                <a:latin typeface="Space Grotesk"/>
+              </a:rPr>
+              <a:t>RVA Builds?</a:t>
+            </a:r>
+          </a:p>
+        </p:txBody>
+      </p:sp>
+      <p:sp>
+        <p:nvSpPr>
+          <p:cNvPr id="6" name="TextBox 5"/>
+          <p:cNvSpPr txBox="1"/>
+          <p:nvPr/>
+        </p:nvSpPr>
+        <p:spPr>
+          <a:xfrm>
+            <a:off x="411480" y="3703320"/>
+            <a:ext cx="3322216" cy="1280160"/>
+          </a:xfrm>
+          <a:prstGeom prst="rect">
+            <a:avLst/>
+          </a:prstGeom>
+          <a:noFill/>
+        </p:spPr>
+        <p:txBody>
+          <a:bodyPr wrap="square" anchor="t" lIns="0" rIns="0" tIns="0" bIns="0">
+            <a:spAutoFit/>
+          </a:bodyPr>
+          <a:lstStyle/>
+          <a:p>
+            <a:pPr algn="ctr">
+              <a:lnSpc>
+                <a:spcPct val="135000"/>
+              </a:lnSpc>
+            </a:pPr>
+            <a:r>
+              <a:rPr sz="1300" b="0">
+                <a:solidFill>
+                  <a:srgbClr val="CCCCCC"/>
+                </a:solidFill>
+                <a:latin typeface="Schibsted Grotesk"/>
+              </a:rPr>
+              <a:t>RVA Builds connects Richmond Public Schools students with paid, hands-on careers in construction and the skilled trades — before they even graduate. A Richmond Ed Fund initiative, backed by Bloomberg Philanthropies.</a:t>
+            </a:r>
+          </a:p>
+        </p:txBody>
+      </p:sp>
+      <p:cxnSp>
+        <p:nvCxnSpPr>
+          <p:cNvPr id="7" name="Connector 6"/>
+          <p:cNvCxnSpPr/>
+          <p:nvPr/>
+        </p:nvCxnSpPr>
+        <p:spPr>
+          <a:xfrm>
+            <a:off x="5150915.5" y="2331720"/>
+            <a:ext cx="6035040.0" cy="0"/>
+          </a:xfrm>
+          <a:prstGeom prst="line">
+            <a:avLst/>
+          </a:prstGeom>
+          <a:ln w="12700">
+            <a:solidFill>
+              <a:srgbClr val="E4E4E4"/>
+            </a:solidFill>
+          </a:ln>
+        </p:spPr>
+        <p:style>
+          <a:lnRef idx="2">
+            <a:schemeClr val="accent1"/>
+          </a:lnRef>
+          <a:fillRef idx="0">
+            <a:schemeClr val="accent1"/>
+          </a:fillRef>
+          <a:effectRef idx="1">
+            <a:schemeClr val="accent1"/>
+          </a:effectRef>
+          <a:fontRef idx="minor">
+            <a:schemeClr val="tx1"/>
+          </a:fontRef>
+        </p:style>
+      </p:cxnSp>
+      <p:cxnSp>
+        <p:nvCxnSpPr>
+          <p:cNvPr id="8" name="Connector 7"/>
+          <p:cNvCxnSpPr/>
+          <p:nvPr/>
+        </p:nvCxnSpPr>
+        <p:spPr>
+          <a:xfrm>
+            <a:off x="5150915.5" y="3566160"/>
+            <a:ext cx="6035040.0" cy="0"/>
+          </a:xfrm>
+          <a:prstGeom prst="line">
+            <a:avLst/>
+          </a:prstGeom>
+          <a:ln w="12700">
+            <a:solidFill>
+              <a:srgbClr val="E4E4E4"/>
+            </a:solidFill>
+          </a:ln>
+        </p:spPr>
+        <p:style>
+          <a:lnRef idx="2">
+            <a:schemeClr val="accent1"/>
+          </a:lnRef>
+          <a:fillRef idx="0">
+            <a:schemeClr val="accent1"/>
+          </a:fillRef>
+          <a:effectRef idx="1">
+            <a:schemeClr val="accent1"/>
+          </a:effectRef>
+          <a:fontRef idx="minor">
+            <a:schemeClr val="tx1"/>
+          </a:fontRef>
+        </p:style>
+      </p:cxnSp>
+      <p:sp>
+        <p:nvSpPr>
+          <p:cNvPr id="9" name="TextBox 8"/>
+          <p:cNvSpPr txBox="1"/>
+          <p:nvPr/>
+        </p:nvSpPr>
+        <p:spPr>
+          <a:xfrm>
+            <a:off x="5150915" y="2514600"/>
+            <a:ext cx="1371600" cy="548640"/>
+          </a:xfrm>
+          <a:prstGeom prst="rect">
+            <a:avLst/>
+          </a:prstGeom>
+          <a:noFill/>
+        </p:spPr>
+        <p:txBody>
+          <a:bodyPr wrap="square" anchor="t" lIns="0" rIns="0" tIns="0" bIns="0">
+            <a:spAutoFit/>
+          </a:bodyPr>
+          <a:lstStyle/>
+          <a:p>
             <a:pPr algn="l">
               <a:lnSpc>
                 <a:spcPct val="100000"/>
               </a:lnSpc>
             </a:pPr>
             <a:r>
-              <a:rPr sz="4400" b="1">
-                <a:solidFill>
-                  <a:srgbClr val="FFFFFF"/>
+              <a:rPr sz="3200" b="1">
+                <a:solidFill>
+                  <a:srgbClr val="1A1A1A"/>
                 </a:solidFill>
                 <a:latin typeface="Space Grotesk"/>
               </a:rPr>
-              <a:t>MEDIA</a:t>
-            </a:r>
-          </a:p>
+              <a:t>150</a:t>
+            </a:r>
+          </a:p>
+        </p:txBody>
+      </p:sp>
+      <p:sp>
+        <p:nvSpPr>
+          <p:cNvPr id="10" name="TextBox 9"/>
+          <p:cNvSpPr txBox="1"/>
+          <p:nvPr/>
+        </p:nvSpPr>
+        <p:spPr>
+          <a:xfrm>
+            <a:off x="5150915" y="3108960"/>
+            <a:ext cx="1371600" cy="502920"/>
+          </a:xfrm>
+          <a:prstGeom prst="rect">
+            <a:avLst/>
+          </a:prstGeom>
+          <a:noFill/>
+        </p:spPr>
+        <p:txBody>
+          <a:bodyPr wrap="square" anchor="t" lIns="0" rIns="0" tIns="0" bIns="0">
+            <a:spAutoFit/>
+          </a:bodyPr>
+          <a:lstStyle/>
           <a:p>
             <a:pPr algn="l">
               <a:lnSpc>
+                <a:spcPct val="115000"/>
+              </a:lnSpc>
+            </a:pPr>
+            <a:r>
+              <a:rPr sz="1050" b="0">
+                <a:solidFill>
+                  <a:srgbClr val="5A5A5A"/>
+                </a:solidFill>
+                <a:latin typeface="Schibsted Grotesk"/>
+              </a:rPr>
+              <a:t>RPS grads aimed at registered</a:t>
+            </a:r>
+          </a:p>
+          <a:p>
+            <a:pPr algn="l">
+              <a:lnSpc>
+                <a:spcPct val="115000"/>
+              </a:lnSpc>
+            </a:pPr>
+            <a:r>
+              <a:rPr sz="1050" b="0">
+                <a:solidFill>
+                  <a:srgbClr val="5A5A5A"/>
+                </a:solidFill>
+                <a:latin typeface="Schibsted Grotesk"/>
+              </a:rPr>
+              <a:t>apprenticeships in 3 years</a:t>
+            </a:r>
+          </a:p>
+        </p:txBody>
+      </p:sp>
+      <p:sp>
+        <p:nvSpPr>
+          <p:cNvPr id="11" name="TextBox 10"/>
+          <p:cNvSpPr txBox="1"/>
+          <p:nvPr/>
+        </p:nvSpPr>
+        <p:spPr>
+          <a:xfrm>
+            <a:off x="6659675" y="2514600"/>
+            <a:ext cx="1371600" cy="548640"/>
+          </a:xfrm>
+          <a:prstGeom prst="rect">
+            <a:avLst/>
+          </a:prstGeom>
+          <a:noFill/>
+        </p:spPr>
+        <p:txBody>
+          <a:bodyPr wrap="square" anchor="t" lIns="0" rIns="0" tIns="0" bIns="0">
+            <a:spAutoFit/>
+          </a:bodyPr>
+          <a:lstStyle/>
+          <a:p>
+            <a:pPr algn="l">
+              <a:lnSpc>
                 <a:spcPct val="100000"/>
               </a:lnSpc>
             </a:pPr>
             <a:r>
-              <a:rPr sz="4400" b="1">
-                <a:solidFill>
-                  <a:srgbClr val="FFFFFF"/>
+              <a:rPr sz="3200" b="1">
+                <a:solidFill>
+                  <a:srgbClr val="1A1A1A"/>
                 </a:solidFill>
                 <a:latin typeface="Space Grotesk"/>
               </a:rPr>
-              <a:t>KIT</a:t>
+              <a:t>500</a:t>
+            </a:r>
+          </a:p>
+        </p:txBody>
+      </p:sp>
+      <p:sp>
+        <p:nvSpPr>
+          <p:cNvPr id="12" name="TextBox 11"/>
+          <p:cNvSpPr txBox="1"/>
+          <p:nvPr/>
+        </p:nvSpPr>
+        <p:spPr>
+          <a:xfrm>
+            <a:off x="6659675" y="3108960"/>
+            <a:ext cx="1371600" cy="502920"/>
+          </a:xfrm>
+          <a:prstGeom prst="rect">
+            <a:avLst/>
+          </a:prstGeom>
+          <a:noFill/>
+        </p:spPr>
+        <p:txBody>
+          <a:bodyPr wrap="square" anchor="t" lIns="0" rIns="0" tIns="0" bIns="0">
+            <a:spAutoFit/>
+          </a:bodyPr>
+          <a:lstStyle/>
+          <a:p>
+            <a:pPr algn="l">
+              <a:lnSpc>
+                <a:spcPct val="115000"/>
+              </a:lnSpc>
+            </a:pPr>
+            <a:r>
+              <a:rPr sz="1050" b="0">
+                <a:solidFill>
+                  <a:srgbClr val="5A5A5A"/>
+                </a:solidFill>
+                <a:latin typeface="Schibsted Grotesk"/>
+              </a:rPr>
+              <a:t>Students in paid trades</a:t>
+            </a:r>
+          </a:p>
+          <a:p>
+            <a:pPr algn="l">
+              <a:lnSpc>
+                <a:spcPct val="115000"/>
+              </a:lnSpc>
+            </a:pPr>
+            <a:r>
+              <a:rPr sz="1050" b="0">
+                <a:solidFill>
+                  <a:srgbClr val="5A5A5A"/>
+                </a:solidFill>
+                <a:latin typeface="Schibsted Grotesk"/>
+              </a:rPr>
+              <a:t>learning by 2028–29 (goal)</a:t>
+            </a:r>
+          </a:p>
+        </p:txBody>
+      </p:sp>
+      <p:sp>
+        <p:nvSpPr>
+          <p:cNvPr id="13" name="TextBox 12"/>
+          <p:cNvSpPr txBox="1"/>
+          <p:nvPr/>
+        </p:nvSpPr>
+        <p:spPr>
+          <a:xfrm>
+            <a:off x="8168435" y="2514600"/>
+            <a:ext cx="1371600" cy="548640"/>
+          </a:xfrm>
+          <a:prstGeom prst="rect">
+            <a:avLst/>
+          </a:prstGeom>
+          <a:noFill/>
+        </p:spPr>
+        <p:txBody>
+          <a:bodyPr wrap="square" anchor="t" lIns="0" rIns="0" tIns="0" bIns="0">
+            <a:spAutoFit/>
+          </a:bodyPr>
+          <a:lstStyle/>
+          <a:p>
+            <a:pPr algn="l">
+              <a:lnSpc>
+                <a:spcPct val="100000"/>
+              </a:lnSpc>
+            </a:pPr>
+            <a:r>
+              <a:rPr sz="3200" b="1">
+                <a:solidFill>
+                  <a:srgbClr val="1A1A1A"/>
+                </a:solidFill>
+                <a:latin typeface="Space Grotesk"/>
+              </a:rPr>
+              <a:t>17</a:t>
+            </a:r>
+          </a:p>
+        </p:txBody>
+      </p:sp>
+      <p:sp>
+        <p:nvSpPr>
+          <p:cNvPr id="14" name="TextBox 13"/>
+          <p:cNvSpPr txBox="1"/>
+          <p:nvPr/>
+        </p:nvSpPr>
+        <p:spPr>
+          <a:xfrm>
+            <a:off x="8168435" y="3108960"/>
+            <a:ext cx="1371600" cy="502920"/>
+          </a:xfrm>
+          <a:prstGeom prst="rect">
+            <a:avLst/>
+          </a:prstGeom>
+          <a:noFill/>
+        </p:spPr>
+        <p:txBody>
+          <a:bodyPr wrap="square" anchor="t" lIns="0" rIns="0" tIns="0" bIns="0">
+            <a:spAutoFit/>
+          </a:bodyPr>
+          <a:lstStyle/>
+          <a:p>
+            <a:pPr algn="l">
+              <a:lnSpc>
+                <a:spcPct val="115000"/>
+              </a:lnSpc>
+            </a:pPr>
+            <a:r>
+              <a:rPr sz="1050" b="0">
+                <a:solidFill>
+                  <a:srgbClr val="5A5A5A"/>
+                </a:solidFill>
+                <a:latin typeface="Schibsted Grotesk"/>
+              </a:rPr>
+              <a:t>Partners: schools, the city,</a:t>
+            </a:r>
+          </a:p>
+          <a:p>
+            <a:pPr algn="l">
+              <a:lnSpc>
+                <a:spcPct val="115000"/>
+              </a:lnSpc>
+            </a:pPr>
+            <a:r>
+              <a:rPr sz="1050" b="0">
+                <a:solidFill>
+                  <a:srgbClr val="5A5A5A"/>
+                </a:solidFill>
+                <a:latin typeface="Schibsted Grotesk"/>
+              </a:rPr>
+              <a:t>business &amp; unions</a:t>
+            </a:r>
+          </a:p>
+        </p:txBody>
+      </p:sp>
+      <p:sp>
+        <p:nvSpPr>
+          <p:cNvPr id="15" name="TextBox 14"/>
+          <p:cNvSpPr txBox="1"/>
+          <p:nvPr/>
+        </p:nvSpPr>
+        <p:spPr>
+          <a:xfrm>
+            <a:off x="9677195" y="2514600"/>
+            <a:ext cx="1371600" cy="548640"/>
+          </a:xfrm>
+          <a:prstGeom prst="rect">
+            <a:avLst/>
+          </a:prstGeom>
+          <a:noFill/>
+        </p:spPr>
+        <p:txBody>
+          <a:bodyPr wrap="square" anchor="t" lIns="0" rIns="0" tIns="0" bIns="0">
+            <a:spAutoFit/>
+          </a:bodyPr>
+          <a:lstStyle/>
+          <a:p>
+            <a:pPr algn="l">
+              <a:lnSpc>
+                <a:spcPct val="100000"/>
+              </a:lnSpc>
+            </a:pPr>
+            <a:r>
+              <a:rPr sz="3200" b="1">
+                <a:solidFill>
+                  <a:srgbClr val="1A1A1A"/>
+                </a:solidFill>
+                <a:latin typeface="Space Grotesk"/>
+              </a:rPr>
+              <a:t>120+</a:t>
+            </a:r>
+          </a:p>
+        </p:txBody>
+      </p:sp>
+      <p:sp>
+        <p:nvSpPr>
+          <p:cNvPr id="16" name="TextBox 15"/>
+          <p:cNvSpPr txBox="1"/>
+          <p:nvPr/>
+        </p:nvSpPr>
+        <p:spPr>
+          <a:xfrm>
+            <a:off x="9677195" y="3108960"/>
+            <a:ext cx="1371600" cy="502920"/>
+          </a:xfrm>
+          <a:prstGeom prst="rect">
+            <a:avLst/>
+          </a:prstGeom>
+          <a:noFill/>
+        </p:spPr>
+        <p:txBody>
+          <a:bodyPr wrap="square" anchor="t" lIns="0" rIns="0" tIns="0" bIns="0">
+            <a:spAutoFit/>
+          </a:bodyPr>
+          <a:lstStyle/>
+          <a:p>
+            <a:pPr algn="l">
+              <a:lnSpc>
+                <a:spcPct val="115000"/>
+              </a:lnSpc>
+            </a:pPr>
+            <a:r>
+              <a:rPr sz="1050" b="0">
+                <a:solidFill>
+                  <a:srgbClr val="5A5A5A"/>
+                </a:solidFill>
+                <a:latin typeface="Schibsted Grotesk"/>
+              </a:rPr>
+              <a:t>Paid work-based learning</a:t>
+            </a:r>
+          </a:p>
+          <a:p>
+            <a:pPr algn="l">
+              <a:lnSpc>
+                <a:spcPct val="115000"/>
+              </a:lnSpc>
+            </a:pPr>
+            <a:r>
+              <a:rPr sz="1050" b="0">
+                <a:solidFill>
+                  <a:srgbClr val="5A5A5A"/>
+                </a:solidFill>
+                <a:latin typeface="Schibsted Grotesk"/>
+              </a:rPr>
+              <a:t>hours per student</a:t>
+            </a:r>
+          </a:p>
+        </p:txBody>
+      </p:sp>
+      <p:sp>
+        <p:nvSpPr>
+          <p:cNvPr id="17" name="TextBox 16"/>
+          <p:cNvSpPr txBox="1"/>
+          <p:nvPr/>
+        </p:nvSpPr>
+        <p:spPr>
+          <a:xfrm>
+            <a:off x="4145176" y="4023360"/>
+            <a:ext cx="8046519" cy="548640"/>
+          </a:xfrm>
+          <a:prstGeom prst="rect">
+            <a:avLst/>
+          </a:prstGeom>
+          <a:noFill/>
+        </p:spPr>
+        <p:txBody>
+          <a:bodyPr wrap="square" anchor="t" lIns="0" rIns="0">
+            <a:spAutoFit/>
+          </a:bodyPr>
+          <a:lstStyle/>
+          <a:p>
+            <a:pPr algn="ctr">
+              <a:lnSpc>
+                <a:spcPct val="100000"/>
+              </a:lnSpc>
+            </a:pPr>
+            <a:r>
+              <a:rPr sz="1900" b="1">
+                <a:solidFill>
+                  <a:srgbClr val="1A1A1A"/>
+                </a:solidFill>
+                <a:latin typeface="Space Grotesk"/>
+              </a:rPr>
+              <a:t>Build a career in the trades, </a:t>
+            </a:r>
+            <a:r>
+              <a:rPr sz="1900" b="1">
+                <a:solidFill>
+                  <a:srgbClr val="F15C2C"/>
+                </a:solidFill>
+                <a:latin typeface="Space Grotesk"/>
+              </a:rPr>
+              <a:t>before you graduate.</a:t>
             </a:r>
           </a:p>
         </p:txBody>

</xml_diff>